<commit_message>
Improve reproducibility: resolve local imports via sys.path, add README/.gitignore, update PPTX captions to American English
Co-Authored-By: Tatsuki Onishi <bougtoir@gmail.com>
</commit_message>
<xml_diff>
--- a/output/sits9_figures.pptx
+++ b/output/sits9_figures.pptx
@@ -3185,7 +3185,7 @@
           <a:p>
             <a:r>
               <a:rPr sz="1400" i="1"/>
-              <a:t>Figure 1. SITS9 Loom Renderer output for Pachelbel's Canon (I-V-vi-iii-IV-I-IV-V, 2 loops). Red solid lines = surface stitches; grey dashed lines = back stitches; filled black circles = anchor points (knots).</a:t>
+              <a:t>Figure 1. SITS9 Loom Renderer output for Pachelbel's Canon (I-V-vi-iii-IV-I-IV-V, 2 loops). Red solid lines = surface stitches; gray dashed lines = back stitches; filled black circles = anchor points (knots).</a:t>
             </a:r>
           </a:p>
         </p:txBody>
@@ -3302,7 +3302,7 @@
           <a:p>
             <a:r>
               <a:rPr sz="1400" i="1"/>
-              <a:t>Figure 2. Harmonic tension profile of Pachelbel's Canon encoded as SITS9 instructions. Bar colour = instruction type (blue = ANCHOR, red = FWD, green = RET). Bar height = TENSION. Dashed line traces the tension arc.</a:t>
+              <a:t>Figure 2. Harmonic tension profile of Pachelbel's Canon encoded as SITS9 instructions. Bar color = instruction type (blue = ANCHOR, red = FWD, green = RET). Bar height = TENSION. Dashed line traces the tension arc.</a:t>
             </a:r>
           </a:p>
         </p:txBody>

</xml_diff>